<commit_message>
docs(presentation): add Vault and the passphrase-once flow to the slides
Update the web slides and the PowerPoint: the passphrase is asked once and
a locked backup goes to the server, HashiCorp Vault joins the technology
table, and the security highlights mention secrets kept in Vault.
</commit_message>
<xml_diff>
--- a/blog/docs/public/cybersecurity/pgp-presentation/CipherChat-PGP-Presentation.pptx
+++ b/blog/docs/public/cybersecurity/pgp-presentation/CipherChat-PGP-Presentation.pptx
@@ -2138,7 +2138,7 @@
                 <a:ea typeface="Calibri" pitchFamily="34" charset="-122"/>
                 <a:cs typeface="Calibri" pitchFamily="34" charset="-120"/>
               </a:rPr>
-              <a:t>2. The browser creates your keys</a:t>
+              <a:t>2. The browser creates your keys (passphrase asked once)</a:t>
             </a:r>
             <a:endParaRPr lang="en-US" sz="1350" dirty="0"/>
           </a:p>
@@ -2353,7 +2353,7 @@
                 <a:ea typeface="Calibri" pitchFamily="34" charset="-122"/>
                 <a:cs typeface="Calibri" pitchFamily="34" charset="-120"/>
               </a:rPr>
-              <a:t>Only the public key is sent to the server. The private key never leaves the browser.</a:t>
+              <a:t>The server gets the public key and a backup locked with your passphrase. The usable private key stays in the browser, so signing in needs only your password.</a:t>
             </a:r>
             <a:endParaRPr lang="en-US" sz="1400" dirty="0"/>
           </a:p>
@@ -2580,7 +2580,7 @@
         </p:nvGraphicFramePr>
         <p:xfrm>
           <a:off x="548640" y="1143000"/>
-          <a:ext cx="8046720" cy="914400"/>
+          <a:ext cx="8046720" cy="3291840"/>
         </p:xfrm>
         <a:graphic>
           <a:graphicData uri="http://schemas.openxmlformats.org/drawingml/2006/table">
@@ -2590,7 +2590,7 @@
                 <a:gridCol w="2651760"/>
                 <a:gridCol w="5394960"/>
               </a:tblGrid>
-              <a:tr h="356616">
+              <a:tr h="329184">
                 <a:tc>
                   <a:txBody>
                     <a:bodyPr/>
@@ -2728,7 +2728,7 @@
                   </a:tcPr>
                 </a:tc>
               </a:tr>
-              <a:tr h="356616">
+              <a:tr h="329184">
                 <a:tc>
                   <a:txBody>
                     <a:bodyPr/>
@@ -2860,7 +2860,7 @@
                   </a:tcPr>
                 </a:tc>
               </a:tr>
-              <a:tr h="356616">
+              <a:tr h="329184">
                 <a:tc>
                   <a:txBody>
                     <a:bodyPr/>
@@ -2992,7 +2992,7 @@
                   </a:tcPr>
                 </a:tc>
               </a:tr>
-              <a:tr h="356616">
+              <a:tr h="329184">
                 <a:tc>
                   <a:txBody>
                     <a:bodyPr/>
@@ -3124,7 +3124,7 @@
                   </a:tcPr>
                 </a:tc>
               </a:tr>
-              <a:tr h="356616">
+              <a:tr h="329184">
                 <a:tc>
                   <a:txBody>
                     <a:bodyPr/>
@@ -3256,7 +3256,7 @@
                   </a:tcPr>
                 </a:tc>
               </a:tr>
-              <a:tr h="356616">
+              <a:tr h="329184">
                 <a:tc>
                   <a:txBody>
                     <a:bodyPr/>
@@ -3388,7 +3388,7 @@
                   </a:tcPr>
                 </a:tc>
               </a:tr>
-              <a:tr h="356616">
+              <a:tr h="329184">
                 <a:tc>
                   <a:txBody>
                     <a:bodyPr/>
@@ -3520,7 +3520,139 @@
                   </a:tcPr>
                 </a:tc>
               </a:tr>
-              <a:tr h="356616">
+              <a:tr h="329184">
+                <a:tc>
+                  <a:txBody>
+                    <a:bodyPr/>
+                    <a:lstStyle/>
+                    <a:p>
+                      <a:pPr indent="0" marL="0">
+                        <a:buNone/>
+                      </a:pPr>
+                      <a:r>
+                        <a:rPr lang="en-US" sz="1300" b="1" dirty="0">
+                          <a:solidFill>
+                            <a:srgbClr val="4A3B30"/>
+                          </a:solidFill>
+                          <a:latin typeface="Calibri" pitchFamily="34" charset="0"/>
+                          <a:ea typeface="Calibri" pitchFamily="34" charset="-122"/>
+                          <a:cs typeface="Calibri" pitchFamily="34" charset="-120"/>
+                        </a:rPr>
+                        <a:t>HashiCorp Vault</a:t>
+                      </a:r>
+                      <a:endParaRPr lang="en-US" sz="1300" dirty="0">
+                        <a:latin typeface="Calibri" charset="0"/>
+                        <a:ea typeface="Calibri" charset="0"/>
+                        <a:cs typeface="Calibri" charset="0"/>
+                      </a:endParaRPr>
+                    </a:p>
+                  </a:txBody>
+                  <a:tcPr marL="109728" marR="109728" marT="36576" marB="36576" anchor="ctr">
+                    <a:lnL w="9525" cap="flat" cmpd="sng" algn="ctr">
+                      <a:solidFill>
+                        <a:srgbClr val="D6C7B3"/>
+                      </a:solidFill>
+                      <a:prstDash val="solid"/>
+                      <a:round/>
+                      <a:headEnd type="none" w="med" len="med"/>
+                      <a:tailEnd type="none" w="med" len="med"/>
+                    </a:lnL>
+                    <a:lnR w="9525" cap="flat" cmpd="sng" algn="ctr">
+                      <a:solidFill>
+                        <a:srgbClr val="D6C7B3"/>
+                      </a:solidFill>
+                      <a:prstDash val="solid"/>
+                      <a:round/>
+                      <a:headEnd type="none" w="med" len="med"/>
+                      <a:tailEnd type="none" w="med" len="med"/>
+                    </a:lnR>
+                    <a:lnT w="9525" cap="flat" cmpd="sng" algn="ctr">
+                      <a:solidFill>
+                        <a:srgbClr val="D6C7B3"/>
+                      </a:solidFill>
+                      <a:prstDash val="solid"/>
+                      <a:round/>
+                      <a:headEnd type="none" w="med" len="med"/>
+                      <a:tailEnd type="none" w="med" len="med"/>
+                    </a:lnT>
+                    <a:lnB w="9525" cap="flat" cmpd="sng" algn="ctr">
+                      <a:solidFill>
+                        <a:srgbClr val="D6C7B3"/>
+                      </a:solidFill>
+                      <a:prstDash val="solid"/>
+                      <a:round/>
+                      <a:headEnd type="none" w="med" len="med"/>
+                      <a:tailEnd type="none" w="med" len="med"/>
+                    </a:lnB>
+                  </a:tcPr>
+                </a:tc>
+                <a:tc>
+                  <a:txBody>
+                    <a:bodyPr/>
+                    <a:lstStyle/>
+                    <a:p>
+                      <a:pPr indent="0" marL="0">
+                        <a:buNone/>
+                      </a:pPr>
+                      <a:r>
+                        <a:rPr lang="en-US" sz="1300" dirty="0">
+                          <a:solidFill>
+                            <a:srgbClr val="4A3B30"/>
+                          </a:solidFill>
+                          <a:latin typeface="Calibri" pitchFamily="34" charset="0"/>
+                          <a:ea typeface="Calibri" pitchFamily="34" charset="-122"/>
+                          <a:cs typeface="Calibri" pitchFamily="34" charset="-120"/>
+                        </a:rPr>
+                        <a:t>Keeps the server's secrets and adds a second lock to key backups</a:t>
+                      </a:r>
+                      <a:endParaRPr lang="en-US" sz="1300" dirty="0">
+                        <a:latin typeface="Calibri" charset="0"/>
+                        <a:ea typeface="Calibri" charset="0"/>
+                        <a:cs typeface="Calibri" charset="0"/>
+                      </a:endParaRPr>
+                    </a:p>
+                  </a:txBody>
+                  <a:tcPr marL="109728" marR="109728" marT="36576" marB="36576" anchor="ctr">
+                    <a:lnL w="9525" cap="flat" cmpd="sng" algn="ctr">
+                      <a:solidFill>
+                        <a:srgbClr val="D6C7B3"/>
+                      </a:solidFill>
+                      <a:prstDash val="solid"/>
+                      <a:round/>
+                      <a:headEnd type="none" w="med" len="med"/>
+                      <a:tailEnd type="none" w="med" len="med"/>
+                    </a:lnL>
+                    <a:lnR w="9525" cap="flat" cmpd="sng" algn="ctr">
+                      <a:solidFill>
+                        <a:srgbClr val="D6C7B3"/>
+                      </a:solidFill>
+                      <a:prstDash val="solid"/>
+                      <a:round/>
+                      <a:headEnd type="none" w="med" len="med"/>
+                      <a:tailEnd type="none" w="med" len="med"/>
+                    </a:lnR>
+                    <a:lnT w="9525" cap="flat" cmpd="sng" algn="ctr">
+                      <a:solidFill>
+                        <a:srgbClr val="D6C7B3"/>
+                      </a:solidFill>
+                      <a:prstDash val="solid"/>
+                      <a:round/>
+                      <a:headEnd type="none" w="med" len="med"/>
+                      <a:tailEnd type="none" w="med" len="med"/>
+                    </a:lnT>
+                    <a:lnB w="9525" cap="flat" cmpd="sng" algn="ctr">
+                      <a:solidFill>
+                        <a:srgbClr val="D6C7B3"/>
+                      </a:solidFill>
+                      <a:prstDash val="solid"/>
+                      <a:round/>
+                      <a:headEnd type="none" w="med" len="med"/>
+                      <a:tailEnd type="none" w="med" len="med"/>
+                    </a:lnB>
+                  </a:tcPr>
+                </a:tc>
+              </a:tr>
+              <a:tr h="329184">
                 <a:tc>
                   <a:txBody>
                     <a:bodyPr/>
@@ -3652,7 +3784,7 @@
                   </a:tcPr>
                 </a:tc>
               </a:tr>
-              <a:tr h="356616">
+              <a:tr h="329184">
                 <a:tc>
                   <a:txBody>
                     <a:bodyPr/>
@@ -4029,7 +4161,7 @@
                 <a:ea typeface="Calibri" pitchFamily="34" charset="-122"/>
                 <a:cs typeface="Calibri" pitchFamily="34" charset="-120"/>
               </a:rPr>
-              <a:t>it never sees plaintext, private keys or passphrases.</a:t>
+              <a:t>it never sees plaintext, a usable private key or your passphrase. Its own secrets live in HashiCorp Vault.</a:t>
             </a:r>
             <a:endParaRPr lang="en-US" sz="1600" dirty="0"/>
           </a:p>

</xml_diff>